<commit_message>
Update presentation file: Databaser och mobilapputveckling - sammanfattning.pptx
</commit_message>
<xml_diff>
--- a/Databaser och mobilapputveckling - sammanfattning.pptx
+++ b/Databaser och mobilapputveckling - sammanfattning.pptx
@@ -9079,145 +9079,6 @@
       </p:sp>
       <p:sp>
         <p:nvSpPr>
-          <p:cNvPr id="4" name="Rounded Rectangle 3"/>
-          <p:cNvSpPr/>
-          <p:nvPr/>
-        </p:nvSpPr>
-        <p:spPr>
-          <a:xfrm>
-            <a:off x="768096" y="2240280"/>
-            <a:ext cx="10655503" cy="2688336"/>
-          </a:xfrm>
-          <a:prstGeom prst="roundRect">
-            <a:avLst>
-              <a:gd name="adj" fmla="val 4000"/>
-            </a:avLst>
-          </a:prstGeom>
-          <a:solidFill>
-            <a:srgbClr val="1F2430"/>
-          </a:solidFill>
-          <a:ln>
-            <a:noFill/>
-          </a:ln>
-          <a:effectLst/>
-        </p:spPr>
-        <p:style>
-          <a:lnRef idx="1">
-            <a:schemeClr val="accent1"/>
-          </a:lnRef>
-          <a:fillRef idx="3">
-            <a:schemeClr val="accent1"/>
-          </a:fillRef>
-          <a:effectRef idx="2">
-            <a:schemeClr val="accent1"/>
-          </a:effectRef>
-          <a:fontRef idx="minor">
-            <a:schemeClr val="lt1"/>
-          </a:fontRef>
-        </p:style>
-        <p:txBody>
-          <a:bodyPr wrap="none" lIns="274320" tIns="201168" rIns="274320" bIns="201168" rtlCol="0" anchor="t"/>
-          <a:lstStyle/>
-          <a:p>
-            <a:pPr algn="l"/>
-            <a:r>
-              <a:rPr sz="1800">
-                <a:solidFill>
-                  <a:srgbClr val="E6E9EF"/>
-                </a:solidFill>
-                <a:latin typeface="Courier New"/>
-              </a:rPr>
-              <a:t>            posts                                users</a:t>
-            </a:r>
-          </a:p>
-          <a:p>
-            <a:pPr algn="l"/>
-            <a:r>
-              <a:rPr sz="1800">
-                <a:solidFill>
-                  <a:srgbClr val="E6E9EF"/>
-                </a:solidFill>
-                <a:latin typeface="Courier New"/>
-              </a:rPr>
-              <a:t>┌─────┬──────────────┬────────┐        ┌─────┬──────────┐</a:t>
-            </a:r>
-          </a:p>
-          <a:p>
-            <a:pPr algn="l"/>
-            <a:r>
-              <a:rPr sz="1800">
-                <a:solidFill>
-                  <a:srgbClr val="E6E9EF"/>
-                </a:solidFill>
-                <a:latin typeface="Courier New"/>
-              </a:rPr>
-              <a:t>│ id  │ title        │ author │        │ id  │ username │</a:t>
-            </a:r>
-          </a:p>
-          <a:p>
-            <a:pPr algn="l"/>
-            <a:r>
-              <a:rPr sz="1800">
-                <a:solidFill>
-                  <a:srgbClr val="E6E9EF"/>
-                </a:solidFill>
-                <a:latin typeface="Courier New"/>
-              </a:rPr>
-              <a:t>├─────┼──────────────┼────────┤        ├─────┼──────────┤</a:t>
-            </a:r>
-          </a:p>
-          <a:p>
-            <a:pPr algn="l"/>
-            <a:r>
-              <a:rPr sz="1800">
-                <a:solidFill>
-                  <a:srgbClr val="E6E9EF"/>
-                </a:solidFill>
-                <a:latin typeface="Courier New"/>
-              </a:rPr>
-              <a:t>│ p1  │ Höstpromenad │ u1  ───┼───────►│ u1  │ anna     │</a:t>
-            </a:r>
-          </a:p>
-          <a:p>
-            <a:pPr algn="l"/>
-            <a:r>
-              <a:rPr sz="1800">
-                <a:solidFill>
-                  <a:srgbClr val="E6E9EF"/>
-                </a:solidFill>
-                <a:latin typeface="Courier New"/>
-              </a:rPr>
-              <a:t>│ p2  │ Surdegsbröd  │ u2  ───┼───────►│ u2  │ bertil   │</a:t>
-            </a:r>
-          </a:p>
-          <a:p>
-            <a:pPr algn="l"/>
-            <a:r>
-              <a:rPr sz="1800">
-                <a:solidFill>
-                  <a:srgbClr val="E6E9EF"/>
-                </a:solidFill>
-                <a:latin typeface="Courier New"/>
-              </a:rPr>
-              <a:t>│ p3  │ Morgondimma  │ u1  ───┼───────►│ u3  │ cissi    │</a:t>
-            </a:r>
-          </a:p>
-          <a:p>
-            <a:pPr algn="l"/>
-            <a:r>
-              <a:rPr sz="1800">
-                <a:solidFill>
-                  <a:srgbClr val="E6E9EF"/>
-                </a:solidFill>
-                <a:latin typeface="Courier New"/>
-              </a:rPr>
-              <a:t>└─────┴──────────────┴────────┘        └─────┴──────────┘</a:t>
-            </a:r>
-          </a:p>
-        </p:txBody>
-      </p:sp>
-      <p:sp>
-        <p:nvSpPr>
           <p:cNvPr id="5" name="TextBox 4"/>
           <p:cNvSpPr txBox="1"/>
           <p:nvPr/>
@@ -9250,6 +9111,589 @@
                 </a:solidFill>
               </a:rPr>
               <a:t>Annas namn står bara på ett ställe. Inläggen pekar på henne med author = u1. I PocketBase heter det ett relationsfält.</a:t>
+            </a:r>
+          </a:p>
+        </p:txBody>
+      </p:sp>
+      <p:sp>
+        <p:nvSpPr>
+          <p:cNvPr id="6" name="TextBox 5"/>
+          <p:cNvSpPr txBox="1"/>
+          <p:nvPr/>
+        </p:nvSpPr>
+        <p:spPr>
+          <a:xfrm>
+            <a:off x="768096" y="2286000"/>
+            <a:ext cx="2743200" cy="365760"/>
+          </a:xfrm>
+          <a:prstGeom prst="rect">
+            <a:avLst/>
+          </a:prstGeom>
+          <a:noFill/>
+        </p:spPr>
+        <p:txBody>
+          <a:bodyPr wrap="square" lIns="0" rIns="0" tIns="0" bIns="0" anchor="ctr">
+            <a:spAutoFit/>
+          </a:bodyPr>
+          <a:lstStyle/>
+          <a:p>
+            <a:pPr algn="l"/>
+            <a:r>
+              <a:rPr sz="1600" b="1" i="0"/>
+              <a:t>posts</a:t>
+            </a:r>
+          </a:p>
+        </p:txBody>
+      </p:sp>
+      <p:sp>
+        <p:nvSpPr>
+          <p:cNvPr id="7" name="TextBox 6"/>
+          <p:cNvSpPr txBox="1"/>
+          <p:nvPr/>
+        </p:nvSpPr>
+        <p:spPr>
+          <a:xfrm>
+            <a:off x="8321040" y="2286000"/>
+            <a:ext cx="2743200" cy="365760"/>
+          </a:xfrm>
+          <a:prstGeom prst="rect">
+            <a:avLst/>
+          </a:prstGeom>
+          <a:noFill/>
+        </p:spPr>
+        <p:txBody>
+          <a:bodyPr wrap="square" lIns="0" rIns="0" tIns="0" bIns="0" anchor="ctr">
+            <a:spAutoFit/>
+          </a:bodyPr>
+          <a:lstStyle/>
+          <a:p>
+            <a:pPr algn="l"/>
+            <a:r>
+              <a:rPr sz="1600" b="1" i="0"/>
+              <a:t>users</a:t>
+            </a:r>
+          </a:p>
+        </p:txBody>
+      </p:sp>
+      <p:graphicFrame>
+        <p:nvGraphicFramePr>
+          <p:cNvPr id="8" name="Tabell posts"/>
+          <p:cNvGraphicFramePr>
+            <a:graphicFrameLocks noGrp="1"/>
+          </p:cNvGraphicFramePr>
+          <p:nvPr/>
+        </p:nvGraphicFramePr>
+        <p:xfrm>
+          <a:off x="768096" y="2697480"/>
+          <a:ext cx="5120640" cy="1828800"/>
+        </p:xfrm>
+        <a:graphic>
+          <a:graphicData uri="http://schemas.openxmlformats.org/drawingml/2006/table">
+            <a:tbl>
+              <a:tblPr firstRow="1" bandRow="1">
+                <a:tableStyleId>{5C22544A-7EE6-4342-B048-85BDC9FD1C3A}</a:tableStyleId>
+              </a:tblPr>
+              <a:tblGrid>
+                <a:gridCol w="822960"/>
+                <a:gridCol w="3108960"/>
+                <a:gridCol w="1188720"/>
+              </a:tblGrid>
+              <a:tr h="457200">
+                <a:tc>
+                  <a:txBody>
+                    <a:bodyPr/>
+                    <a:lstStyle/>
+                    <a:p>
+                      <a:r>
+                        <a:rPr sz="1600" b="1"/>
+                        <a:t>id</a:t>
+                      </a:r>
+                    </a:p>
+                  </a:txBody>
+                  <a:tcPr anchor="ctr" marL="91440" marR="91440" marT="18288" marB="18288"/>
+                </a:tc>
+                <a:tc>
+                  <a:txBody>
+                    <a:bodyPr/>
+                    <a:lstStyle/>
+                    <a:p>
+                      <a:r>
+                        <a:rPr sz="1600" b="1"/>
+                        <a:t>title</a:t>
+                      </a:r>
+                    </a:p>
+                  </a:txBody>
+                  <a:tcPr anchor="ctr" marL="91440" marR="91440" marT="18288" marB="18288"/>
+                </a:tc>
+                <a:tc>
+                  <a:txBody>
+                    <a:bodyPr/>
+                    <a:lstStyle/>
+                    <a:p>
+                      <a:r>
+                        <a:rPr sz="1600" b="1"/>
+                        <a:t>author</a:t>
+                      </a:r>
+                    </a:p>
+                  </a:txBody>
+                  <a:tcPr anchor="ctr" marL="91440" marR="91440" marT="18288" marB="18288"/>
+                </a:tc>
+              </a:tr>
+              <a:tr h="457200">
+                <a:tc>
+                  <a:txBody>
+                    <a:bodyPr/>
+                    <a:lstStyle/>
+                    <a:p>
+                      <a:r>
+                        <a:rPr sz="1600">
+                          <a:latin typeface="Courier New"/>
+                        </a:rPr>
+                        <a:t>p1</a:t>
+                      </a:r>
+                    </a:p>
+                  </a:txBody>
+                  <a:tcPr anchor="ctr" marL="91440" marR="91440" marT="18288" marB="18288"/>
+                </a:tc>
+                <a:tc>
+                  <a:txBody>
+                    <a:bodyPr/>
+                    <a:lstStyle/>
+                    <a:p>
+                      <a:r>
+                        <a:rPr sz="1600"/>
+                        <a:t>Höstpromenad</a:t>
+                      </a:r>
+                    </a:p>
+                  </a:txBody>
+                  <a:tcPr anchor="ctr" marL="91440" marR="91440" marT="18288" marB="18288"/>
+                </a:tc>
+                <a:tc>
+                  <a:txBody>
+                    <a:bodyPr/>
+                    <a:lstStyle/>
+                    <a:p>
+                      <a:r>
+                        <a:rPr sz="1600">
+                          <a:latin typeface="Courier New"/>
+                        </a:rPr>
+                        <a:t>u1</a:t>
+                      </a:r>
+                    </a:p>
+                  </a:txBody>
+                  <a:tcPr anchor="ctr" marL="91440" marR="91440" marT="18288" marB="18288"/>
+                </a:tc>
+              </a:tr>
+              <a:tr h="457200">
+                <a:tc>
+                  <a:txBody>
+                    <a:bodyPr/>
+                    <a:lstStyle/>
+                    <a:p>
+                      <a:r>
+                        <a:rPr sz="1600">
+                          <a:latin typeface="Courier New"/>
+                        </a:rPr>
+                        <a:t>p2</a:t>
+                      </a:r>
+                    </a:p>
+                  </a:txBody>
+                  <a:tcPr anchor="ctr" marL="91440" marR="91440" marT="18288" marB="18288"/>
+                </a:tc>
+                <a:tc>
+                  <a:txBody>
+                    <a:bodyPr/>
+                    <a:lstStyle/>
+                    <a:p>
+                      <a:r>
+                        <a:rPr sz="1600"/>
+                        <a:t>Surdegsbröd</a:t>
+                      </a:r>
+                    </a:p>
+                  </a:txBody>
+                  <a:tcPr anchor="ctr" marL="91440" marR="91440" marT="18288" marB="18288"/>
+                </a:tc>
+                <a:tc>
+                  <a:txBody>
+                    <a:bodyPr/>
+                    <a:lstStyle/>
+                    <a:p>
+                      <a:r>
+                        <a:rPr sz="1600">
+                          <a:latin typeface="Courier New"/>
+                        </a:rPr>
+                        <a:t>u2</a:t>
+                      </a:r>
+                    </a:p>
+                  </a:txBody>
+                  <a:tcPr anchor="ctr" marL="91440" marR="91440" marT="18288" marB="18288"/>
+                </a:tc>
+              </a:tr>
+              <a:tr h="457200">
+                <a:tc>
+                  <a:txBody>
+                    <a:bodyPr/>
+                    <a:lstStyle/>
+                    <a:p>
+                      <a:r>
+                        <a:rPr sz="1600">
+                          <a:latin typeface="Courier New"/>
+                        </a:rPr>
+                        <a:t>p3</a:t>
+                      </a:r>
+                    </a:p>
+                  </a:txBody>
+                  <a:tcPr anchor="ctr" marL="91440" marR="91440" marT="18288" marB="18288"/>
+                </a:tc>
+                <a:tc>
+                  <a:txBody>
+                    <a:bodyPr/>
+                    <a:lstStyle/>
+                    <a:p>
+                      <a:r>
+                        <a:rPr sz="1600"/>
+                        <a:t>Morgondimma</a:t>
+                      </a:r>
+                    </a:p>
+                  </a:txBody>
+                  <a:tcPr anchor="ctr" marL="91440" marR="91440" marT="18288" marB="18288"/>
+                </a:tc>
+                <a:tc>
+                  <a:txBody>
+                    <a:bodyPr/>
+                    <a:lstStyle/>
+                    <a:p>
+                      <a:r>
+                        <a:rPr sz="1600">
+                          <a:latin typeface="Courier New"/>
+                        </a:rPr>
+                        <a:t>u1</a:t>
+                      </a:r>
+                    </a:p>
+                  </a:txBody>
+                  <a:tcPr anchor="ctr" marL="91440" marR="91440" marT="18288" marB="18288"/>
+                </a:tc>
+              </a:tr>
+            </a:tbl>
+          </a:graphicData>
+        </a:graphic>
+      </p:graphicFrame>
+      <p:graphicFrame>
+        <p:nvGraphicFramePr>
+          <p:cNvPr id="9" name="Tabell users"/>
+          <p:cNvGraphicFramePr>
+            <a:graphicFrameLocks noGrp="1"/>
+          </p:cNvGraphicFramePr>
+          <p:nvPr/>
+        </p:nvGraphicFramePr>
+        <p:xfrm>
+          <a:off x="8321040" y="2697480"/>
+          <a:ext cx="3108960" cy="1828800"/>
+        </p:xfrm>
+        <a:graphic>
+          <a:graphicData uri="http://schemas.openxmlformats.org/drawingml/2006/table">
+            <a:tbl>
+              <a:tblPr firstRow="1" bandRow="1">
+                <a:tableStyleId>{5C22544A-7EE6-4342-B048-85BDC9FD1C3A}</a:tableStyleId>
+              </a:tblPr>
+              <a:tblGrid>
+                <a:gridCol w="1097280"/>
+                <a:gridCol w="2011680"/>
+              </a:tblGrid>
+              <a:tr h="457200">
+                <a:tc>
+                  <a:txBody>
+                    <a:bodyPr/>
+                    <a:lstStyle/>
+                    <a:p>
+                      <a:r>
+                        <a:rPr sz="1600" b="1"/>
+                        <a:t>id</a:t>
+                      </a:r>
+                    </a:p>
+                  </a:txBody>
+                  <a:tcPr anchor="ctr" marL="91440" marR="91440" marT="18288" marB="18288"/>
+                </a:tc>
+                <a:tc>
+                  <a:txBody>
+                    <a:bodyPr/>
+                    <a:lstStyle/>
+                    <a:p>
+                      <a:r>
+                        <a:rPr sz="1600" b="1"/>
+                        <a:t>username</a:t>
+                      </a:r>
+                    </a:p>
+                  </a:txBody>
+                  <a:tcPr anchor="ctr" marL="91440" marR="91440" marT="18288" marB="18288"/>
+                </a:tc>
+              </a:tr>
+              <a:tr h="457200">
+                <a:tc>
+                  <a:txBody>
+                    <a:bodyPr/>
+                    <a:lstStyle/>
+                    <a:p>
+                      <a:r>
+                        <a:rPr sz="1600">
+                          <a:latin typeface="Courier New"/>
+                        </a:rPr>
+                        <a:t>u1</a:t>
+                      </a:r>
+                    </a:p>
+                  </a:txBody>
+                  <a:tcPr anchor="ctr" marL="91440" marR="91440" marT="18288" marB="18288"/>
+                </a:tc>
+                <a:tc>
+                  <a:txBody>
+                    <a:bodyPr/>
+                    <a:lstStyle/>
+                    <a:p>
+                      <a:r>
+                        <a:rPr sz="1600"/>
+                        <a:t>anna</a:t>
+                      </a:r>
+                    </a:p>
+                  </a:txBody>
+                  <a:tcPr anchor="ctr" marL="91440" marR="91440" marT="18288" marB="18288"/>
+                </a:tc>
+              </a:tr>
+              <a:tr h="457200">
+                <a:tc>
+                  <a:txBody>
+                    <a:bodyPr/>
+                    <a:lstStyle/>
+                    <a:p>
+                      <a:r>
+                        <a:rPr sz="1600">
+                          <a:latin typeface="Courier New"/>
+                        </a:rPr>
+                        <a:t>u2</a:t>
+                      </a:r>
+                    </a:p>
+                  </a:txBody>
+                  <a:tcPr anchor="ctr" marL="91440" marR="91440" marT="18288" marB="18288"/>
+                </a:tc>
+                <a:tc>
+                  <a:txBody>
+                    <a:bodyPr/>
+                    <a:lstStyle/>
+                    <a:p>
+                      <a:r>
+                        <a:rPr sz="1600"/>
+                        <a:t>bertil</a:t>
+                      </a:r>
+                    </a:p>
+                  </a:txBody>
+                  <a:tcPr anchor="ctr" marL="91440" marR="91440" marT="18288" marB="18288"/>
+                </a:tc>
+              </a:tr>
+              <a:tr h="457200">
+                <a:tc>
+                  <a:txBody>
+                    <a:bodyPr/>
+                    <a:lstStyle/>
+                    <a:p>
+                      <a:r>
+                        <a:rPr sz="1600">
+                          <a:latin typeface="Courier New"/>
+                        </a:rPr>
+                        <a:t>u3</a:t>
+                      </a:r>
+                    </a:p>
+                  </a:txBody>
+                  <a:tcPr anchor="ctr" marL="91440" marR="91440" marT="18288" marB="18288"/>
+                </a:tc>
+                <a:tc>
+                  <a:txBody>
+                    <a:bodyPr/>
+                    <a:lstStyle/>
+                    <a:p>
+                      <a:r>
+                        <a:rPr sz="1600"/>
+                        <a:t>cissi</a:t>
+                      </a:r>
+                    </a:p>
+                  </a:txBody>
+                  <a:tcPr anchor="ctr" marL="91440" marR="91440" marT="18288" marB="18288"/>
+                </a:tc>
+              </a:tr>
+            </a:tbl>
+          </a:graphicData>
+        </a:graphic>
+      </p:graphicFrame>
+      <p:cxnSp>
+        <p:nvCxnSpPr>
+          <p:cNvPr id="10" name="Connector 9"/>
+          <p:cNvCxnSpPr/>
+          <p:nvPr/>
+        </p:nvCxnSpPr>
+        <p:spPr>
+          <a:xfrm>
+            <a:off x="5961888" y="3383280"/>
+            <a:ext cx="2286000" cy="0"/>
+          </a:xfrm>
+          <a:prstGeom prst="line">
+            <a:avLst/>
+          </a:prstGeom>
+          <a:ln w="22225">
+            <a:solidFill>
+              <a:srgbClr val="404040"/>
+            </a:solidFill>
+            <a:tailEnd type="triangle" w="med" len="med"/>
+          </a:ln>
+        </p:spPr>
+        <p:style>
+          <a:lnRef idx="2">
+            <a:schemeClr val="accent1"/>
+          </a:lnRef>
+          <a:fillRef idx="0">
+            <a:schemeClr val="accent1"/>
+          </a:fillRef>
+          <a:effectRef idx="1">
+            <a:schemeClr val="accent1"/>
+          </a:effectRef>
+          <a:fontRef idx="minor">
+            <a:schemeClr val="tx1"/>
+          </a:fontRef>
+        </p:style>
+      </p:cxnSp>
+      <p:cxnSp>
+        <p:nvCxnSpPr>
+          <p:cNvPr id="11" name="Connector 10"/>
+          <p:cNvCxnSpPr/>
+          <p:nvPr/>
+        </p:nvCxnSpPr>
+        <p:spPr>
+          <a:xfrm>
+            <a:off x="5961888" y="3840480"/>
+            <a:ext cx="2286000" cy="0"/>
+          </a:xfrm>
+          <a:prstGeom prst="line">
+            <a:avLst/>
+          </a:prstGeom>
+          <a:ln w="22225">
+            <a:solidFill>
+              <a:srgbClr val="404040"/>
+            </a:solidFill>
+            <a:tailEnd type="triangle" w="med" len="med"/>
+          </a:ln>
+        </p:spPr>
+        <p:style>
+          <a:lnRef idx="2">
+            <a:schemeClr val="accent1"/>
+          </a:lnRef>
+          <a:fillRef idx="0">
+            <a:schemeClr val="accent1"/>
+          </a:fillRef>
+          <a:effectRef idx="1">
+            <a:schemeClr val="accent1"/>
+          </a:effectRef>
+          <a:fontRef idx="minor">
+            <a:schemeClr val="tx1"/>
+          </a:fontRef>
+        </p:style>
+      </p:cxnSp>
+      <p:cxnSp>
+        <p:nvCxnSpPr>
+          <p:cNvPr id="12" name="Connector 11"/>
+          <p:cNvCxnSpPr/>
+          <p:nvPr/>
+        </p:nvCxnSpPr>
+        <p:spPr>
+          <a:xfrm flipV="1">
+            <a:off x="5961888" y="3383280"/>
+            <a:ext cx="2286000" cy="914400"/>
+          </a:xfrm>
+          <a:prstGeom prst="line">
+            <a:avLst/>
+          </a:prstGeom>
+          <a:ln w="22225">
+            <a:solidFill>
+              <a:srgbClr val="404040"/>
+            </a:solidFill>
+            <a:tailEnd type="triangle" w="med" len="med"/>
+          </a:ln>
+        </p:spPr>
+        <p:style>
+          <a:lnRef idx="2">
+            <a:schemeClr val="accent1"/>
+          </a:lnRef>
+          <a:fillRef idx="0">
+            <a:schemeClr val="accent1"/>
+          </a:fillRef>
+          <a:effectRef idx="1">
+            <a:schemeClr val="accent1"/>
+          </a:effectRef>
+          <a:fontRef idx="minor">
+            <a:schemeClr val="tx1"/>
+          </a:fontRef>
+        </p:style>
+      </p:cxnSp>
+      <p:sp>
+        <p:nvSpPr>
+          <p:cNvPr id="13" name="TextBox 12"/>
+          <p:cNvSpPr txBox="1"/>
+          <p:nvPr/>
+        </p:nvSpPr>
+        <p:spPr>
+          <a:xfrm>
+            <a:off x="4700016" y="4572000"/>
+            <a:ext cx="2377440" cy="320040"/>
+          </a:xfrm>
+          <a:prstGeom prst="rect">
+            <a:avLst/>
+          </a:prstGeom>
+          <a:noFill/>
+        </p:spPr>
+        <p:txBody>
+          <a:bodyPr wrap="square" lIns="0" rIns="0" tIns="0" bIns="0" anchor="ctr">
+            <a:spAutoFit/>
+          </a:bodyPr>
+          <a:lstStyle/>
+          <a:p>
+            <a:pPr algn="l"/>
+            <a:r>
+              <a:rPr sz="1300" b="0" i="0">
+                <a:solidFill>
+                  <a:srgbClr val="595959"/>
+                </a:solidFill>
+              </a:rPr>
+              <a:t>↑ främmande nyckel</a:t>
+            </a:r>
+          </a:p>
+        </p:txBody>
+      </p:sp>
+      <p:sp>
+        <p:nvSpPr>
+          <p:cNvPr id="14" name="TextBox 13"/>
+          <p:cNvSpPr txBox="1"/>
+          <p:nvPr/>
+        </p:nvSpPr>
+        <p:spPr>
+          <a:xfrm>
+            <a:off x="8321040" y="4572000"/>
+            <a:ext cx="2377440" cy="320040"/>
+          </a:xfrm>
+          <a:prstGeom prst="rect">
+            <a:avLst/>
+          </a:prstGeom>
+          <a:noFill/>
+        </p:spPr>
+        <p:txBody>
+          <a:bodyPr wrap="square" lIns="0" rIns="0" tIns="0" bIns="0" anchor="ctr">
+            <a:spAutoFit/>
+          </a:bodyPr>
+          <a:lstStyle/>
+          <a:p>
+            <a:pPr algn="l"/>
+            <a:r>
+              <a:rPr sz="1300" b="0" i="0">
+                <a:solidFill>
+                  <a:srgbClr val="595959"/>
+                </a:solidFill>
+              </a:rPr>
+              <a:t>↑ primärnyckel</a:t>
             </a:r>
           </a:p>
         </p:txBody>
@@ -12451,297 +12895,926 @@
           </a:p>
         </p:txBody>
       </p:sp>
-      <p:sp>
-        <p:nvSpPr>
-          <p:cNvPr id="3" name="Rounded Rectangle 2"/>
-          <p:cNvSpPr/>
+      <p:graphicFrame>
+        <p:nvGraphicFramePr>
+          <p:cNvPr id="3" name="ER users"/>
+          <p:cNvGraphicFramePr>
+            <a:graphicFrameLocks noGrp="1"/>
+          </p:cNvGraphicFramePr>
           <p:nvPr/>
-        </p:nvSpPr>
+        </p:nvGraphicFramePr>
+        <p:xfrm>
+          <a:off x="4727448" y="1783080"/>
+          <a:ext cx="2743200" cy="2112264"/>
+        </p:xfrm>
+        <a:graphic>
+          <a:graphicData uri="http://schemas.openxmlformats.org/drawingml/2006/table">
+            <a:tbl>
+              <a:tblPr firstRow="1" bandRow="1">
+                <a:tableStyleId>{5C22544A-7EE6-4342-B048-85BDC9FD1C3A}</a:tableStyleId>
+              </a:tblPr>
+              <a:tblGrid>
+                <a:gridCol w="2743200"/>
+              </a:tblGrid>
+              <a:tr h="301752">
+                <a:tc>
+                  <a:txBody>
+                    <a:bodyPr/>
+                    <a:lstStyle/>
+                    <a:p>
+                      <a:r>
+                        <a:rPr sz="1300" b="1"/>
+                        <a:t>users</a:t>
+                      </a:r>
+                    </a:p>
+                  </a:txBody>
+                  <a:tcPr anchor="ctr" marL="91440" marR="91440" marT="18288" marB="18288"/>
+                </a:tc>
+              </a:tr>
+              <a:tr h="301752">
+                <a:tc>
+                  <a:txBody>
+                    <a:bodyPr/>
+                    <a:lstStyle/>
+                    <a:p>
+                      <a:r>
+                        <a:rPr sz="1300">
+                          <a:latin typeface="Courier New"/>
+                        </a:rPr>
+                        <a:t>id</a:t>
+                      </a:r>
+                    </a:p>
+                  </a:txBody>
+                  <a:tcPr anchor="ctr" marL="91440" marR="91440" marT="18288" marB="18288"/>
+                </a:tc>
+              </a:tr>
+              <a:tr h="301752">
+                <a:tc>
+                  <a:txBody>
+                    <a:bodyPr/>
+                    <a:lstStyle/>
+                    <a:p>
+                      <a:r>
+                        <a:rPr sz="1300">
+                          <a:latin typeface="Courier New"/>
+                        </a:rPr>
+                        <a:t>username (unik)</a:t>
+                      </a:r>
+                    </a:p>
+                  </a:txBody>
+                  <a:tcPr anchor="ctr" marL="91440" marR="91440" marT="18288" marB="18288"/>
+                </a:tc>
+              </a:tr>
+              <a:tr h="301752">
+                <a:tc>
+                  <a:txBody>
+                    <a:bodyPr/>
+                    <a:lstStyle/>
+                    <a:p>
+                      <a:r>
+                        <a:rPr sz="1300">
+                          <a:latin typeface="Courier New"/>
+                        </a:rPr>
+                        <a:t>name</a:t>
+                      </a:r>
+                    </a:p>
+                  </a:txBody>
+                  <a:tcPr anchor="ctr" marL="91440" marR="91440" marT="18288" marB="18288"/>
+                </a:tc>
+              </a:tr>
+              <a:tr h="301752">
+                <a:tc>
+                  <a:txBody>
+                    <a:bodyPr/>
+                    <a:lstStyle/>
+                    <a:p>
+                      <a:r>
+                        <a:rPr sz="1300">
+                          <a:latin typeface="Courier New"/>
+                        </a:rPr>
+                        <a:t>email</a:t>
+                      </a:r>
+                    </a:p>
+                  </a:txBody>
+                  <a:tcPr anchor="ctr" marL="91440" marR="91440" marT="18288" marB="18288"/>
+                </a:tc>
+              </a:tr>
+              <a:tr h="301752">
+                <a:tc>
+                  <a:txBody>
+                    <a:bodyPr/>
+                    <a:lstStyle/>
+                    <a:p>
+                      <a:r>
+                        <a:rPr sz="1300">
+                          <a:latin typeface="Courier New"/>
+                        </a:rPr>
+                        <a:t>bio</a:t>
+                      </a:r>
+                    </a:p>
+                  </a:txBody>
+                  <a:tcPr anchor="ctr" marL="91440" marR="91440" marT="18288" marB="18288"/>
+                </a:tc>
+              </a:tr>
+              <a:tr h="301752">
+                <a:tc>
+                  <a:txBody>
+                    <a:bodyPr/>
+                    <a:lstStyle/>
+                    <a:p>
+                      <a:r>
+                        <a:rPr sz="1300">
+                          <a:latin typeface="Courier New"/>
+                        </a:rPr>
+                        <a:t>website</a:t>
+                      </a:r>
+                    </a:p>
+                  </a:txBody>
+                  <a:tcPr anchor="ctr" marL="91440" marR="91440" marT="18288" marB="18288"/>
+                </a:tc>
+              </a:tr>
+            </a:tbl>
+          </a:graphicData>
+        </a:graphic>
+      </p:graphicFrame>
+      <p:graphicFrame>
+        <p:nvGraphicFramePr>
+          <p:cNvPr id="4" name="ER follows"/>
+          <p:cNvGraphicFramePr>
+            <a:graphicFrameLocks noGrp="1"/>
+          </p:cNvGraphicFramePr>
+          <p:nvPr/>
+        </p:nvGraphicFramePr>
+        <p:xfrm>
+          <a:off x="8686800" y="1783080"/>
+          <a:ext cx="2743200" cy="1508760"/>
+        </p:xfrm>
+        <a:graphic>
+          <a:graphicData uri="http://schemas.openxmlformats.org/drawingml/2006/table">
+            <a:tbl>
+              <a:tblPr firstRow="1" bandRow="1">
+                <a:tableStyleId>{5C22544A-7EE6-4342-B048-85BDC9FD1C3A}</a:tableStyleId>
+              </a:tblPr>
+              <a:tblGrid>
+                <a:gridCol w="2743200"/>
+              </a:tblGrid>
+              <a:tr h="301752">
+                <a:tc>
+                  <a:txBody>
+                    <a:bodyPr/>
+                    <a:lstStyle/>
+                    <a:p>
+                      <a:r>
+                        <a:rPr sz="1300" b="1"/>
+                        <a:t>follows</a:t>
+                      </a:r>
+                    </a:p>
+                  </a:txBody>
+                  <a:tcPr anchor="ctr" marL="91440" marR="91440" marT="18288" marB="18288"/>
+                </a:tc>
+              </a:tr>
+              <a:tr h="301752">
+                <a:tc>
+                  <a:txBody>
+                    <a:bodyPr/>
+                    <a:lstStyle/>
+                    <a:p>
+                      <a:r>
+                        <a:rPr sz="1300">
+                          <a:latin typeface="Courier New"/>
+                        </a:rPr>
+                        <a:t>id</a:t>
+                      </a:r>
+                    </a:p>
+                  </a:txBody>
+                  <a:tcPr anchor="ctr" marL="91440" marR="91440" marT="18288" marB="18288"/>
+                </a:tc>
+              </a:tr>
+              <a:tr h="301752">
+                <a:tc>
+                  <a:txBody>
+                    <a:bodyPr/>
+                    <a:lstStyle/>
+                    <a:p>
+                      <a:r>
+                        <a:rPr sz="1300" b="1">
+                          <a:latin typeface="Courier New"/>
+                        </a:rPr>
+                        <a:t>follower  → users</a:t>
+                      </a:r>
+                    </a:p>
+                  </a:txBody>
+                  <a:tcPr anchor="ctr" marL="91440" marR="91440" marT="18288" marB="18288"/>
+                </a:tc>
+              </a:tr>
+              <a:tr h="301752">
+                <a:tc>
+                  <a:txBody>
+                    <a:bodyPr/>
+                    <a:lstStyle/>
+                    <a:p>
+                      <a:r>
+                        <a:rPr sz="1300" b="1">
+                          <a:latin typeface="Courier New"/>
+                        </a:rPr>
+                        <a:t>following → users</a:t>
+                      </a:r>
+                    </a:p>
+                  </a:txBody>
+                  <a:tcPr anchor="ctr" marL="91440" marR="91440" marT="18288" marB="18288"/>
+                </a:tc>
+              </a:tr>
+              <a:tr h="301752">
+                <a:tc>
+                  <a:txBody>
+                    <a:bodyPr/>
+                    <a:lstStyle/>
+                    <a:p>
+                      <a:r>
+                        <a:rPr sz="1300">
+                          <a:latin typeface="Courier New"/>
+                        </a:rPr>
+                        <a:t>created</a:t>
+                      </a:r>
+                    </a:p>
+                  </a:txBody>
+                  <a:tcPr anchor="ctr" marL="91440" marR="91440" marT="18288" marB="18288"/>
+                </a:tc>
+              </a:tr>
+            </a:tbl>
+          </a:graphicData>
+        </a:graphic>
+      </p:graphicFrame>
+      <p:graphicFrame>
+        <p:nvGraphicFramePr>
+          <p:cNvPr id="5" name="ER posts"/>
+          <p:cNvGraphicFramePr>
+            <a:graphicFrameLocks noGrp="1"/>
+          </p:cNvGraphicFramePr>
+          <p:nvPr/>
+        </p:nvGraphicFramePr>
+        <p:xfrm>
+          <a:off x="4727448" y="4389120"/>
+          <a:ext cx="2743200" cy="1810512"/>
+        </p:xfrm>
+        <a:graphic>
+          <a:graphicData uri="http://schemas.openxmlformats.org/drawingml/2006/table">
+            <a:tbl>
+              <a:tblPr firstRow="1" bandRow="1">
+                <a:tableStyleId>{5C22544A-7EE6-4342-B048-85BDC9FD1C3A}</a:tableStyleId>
+              </a:tblPr>
+              <a:tblGrid>
+                <a:gridCol w="2743200"/>
+              </a:tblGrid>
+              <a:tr h="301752">
+                <a:tc>
+                  <a:txBody>
+                    <a:bodyPr/>
+                    <a:lstStyle/>
+                    <a:p>
+                      <a:r>
+                        <a:rPr sz="1300" b="1"/>
+                        <a:t>posts</a:t>
+                      </a:r>
+                    </a:p>
+                  </a:txBody>
+                  <a:tcPr anchor="ctr" marL="91440" marR="91440" marT="18288" marB="18288"/>
+                </a:tc>
+              </a:tr>
+              <a:tr h="301752">
+                <a:tc>
+                  <a:txBody>
+                    <a:bodyPr/>
+                    <a:lstStyle/>
+                    <a:p>
+                      <a:r>
+                        <a:rPr sz="1300">
+                          <a:latin typeface="Courier New"/>
+                        </a:rPr>
+                        <a:t>id</a:t>
+                      </a:r>
+                    </a:p>
+                  </a:txBody>
+                  <a:tcPr anchor="ctr" marL="91440" marR="91440" marT="18288" marB="18288"/>
+                </a:tc>
+              </a:tr>
+              <a:tr h="301752">
+                <a:tc>
+                  <a:txBody>
+                    <a:bodyPr/>
+                    <a:lstStyle/>
+                    <a:p>
+                      <a:r>
+                        <a:rPr sz="1300" b="1">
+                          <a:latin typeface="Courier New"/>
+                        </a:rPr>
+                        <a:t>author → users</a:t>
+                      </a:r>
+                    </a:p>
+                  </a:txBody>
+                  <a:tcPr anchor="ctr" marL="91440" marR="91440" marT="18288" marB="18288"/>
+                </a:tc>
+              </a:tr>
+              <a:tr h="301752">
+                <a:tc>
+                  <a:txBody>
+                    <a:bodyPr/>
+                    <a:lstStyle/>
+                    <a:p>
+                      <a:r>
+                        <a:rPr sz="1300">
+                          <a:latin typeface="Courier New"/>
+                        </a:rPr>
+                        <a:t>title</a:t>
+                      </a:r>
+                    </a:p>
+                  </a:txBody>
+                  <a:tcPr anchor="ctr" marL="91440" marR="91440" marT="18288" marB="18288"/>
+                </a:tc>
+              </a:tr>
+              <a:tr h="301752">
+                <a:tc>
+                  <a:txBody>
+                    <a:bodyPr/>
+                    <a:lstStyle/>
+                    <a:p>
+                      <a:r>
+                        <a:rPr sz="1300">
+                          <a:latin typeface="Courier New"/>
+                        </a:rPr>
+                        <a:t>body</a:t>
+                      </a:r>
+                    </a:p>
+                  </a:txBody>
+                  <a:tcPr anchor="ctr" marL="91440" marR="91440" marT="18288" marB="18288"/>
+                </a:tc>
+              </a:tr>
+              <a:tr h="301752">
+                <a:tc>
+                  <a:txBody>
+                    <a:bodyPr/>
+                    <a:lstStyle/>
+                    <a:p>
+                      <a:r>
+                        <a:rPr sz="1300">
+                          <a:latin typeface="Courier New"/>
+                        </a:rPr>
+                        <a:t>created</a:t>
+                      </a:r>
+                    </a:p>
+                  </a:txBody>
+                  <a:tcPr anchor="ctr" marL="91440" marR="91440" marT="18288" marB="18288"/>
+                </a:tc>
+              </a:tr>
+            </a:tbl>
+          </a:graphicData>
+        </a:graphic>
+      </p:graphicFrame>
+      <p:graphicFrame>
+        <p:nvGraphicFramePr>
+          <p:cNvPr id="6" name="ER comments"/>
+          <p:cNvGraphicFramePr>
+            <a:graphicFrameLocks noGrp="1"/>
+          </p:cNvGraphicFramePr>
+          <p:nvPr/>
+        </p:nvGraphicFramePr>
+        <p:xfrm>
+          <a:off x="768096" y="4389120"/>
+          <a:ext cx="2743200" cy="1810512"/>
+        </p:xfrm>
+        <a:graphic>
+          <a:graphicData uri="http://schemas.openxmlformats.org/drawingml/2006/table">
+            <a:tbl>
+              <a:tblPr firstRow="1" bandRow="1">
+                <a:tableStyleId>{5C22544A-7EE6-4342-B048-85BDC9FD1C3A}</a:tableStyleId>
+              </a:tblPr>
+              <a:tblGrid>
+                <a:gridCol w="2743200"/>
+              </a:tblGrid>
+              <a:tr h="301752">
+                <a:tc>
+                  <a:txBody>
+                    <a:bodyPr/>
+                    <a:lstStyle/>
+                    <a:p>
+                      <a:r>
+                        <a:rPr sz="1300" b="1"/>
+                        <a:t>comments</a:t>
+                      </a:r>
+                    </a:p>
+                  </a:txBody>
+                  <a:tcPr anchor="ctr" marL="91440" marR="91440" marT="18288" marB="18288"/>
+                </a:tc>
+              </a:tr>
+              <a:tr h="301752">
+                <a:tc>
+                  <a:txBody>
+                    <a:bodyPr/>
+                    <a:lstStyle/>
+                    <a:p>
+                      <a:r>
+                        <a:rPr sz="1300">
+                          <a:latin typeface="Courier New"/>
+                        </a:rPr>
+                        <a:t>id</a:t>
+                      </a:r>
+                    </a:p>
+                  </a:txBody>
+                  <a:tcPr anchor="ctr" marL="91440" marR="91440" marT="18288" marB="18288"/>
+                </a:tc>
+              </a:tr>
+              <a:tr h="301752">
+                <a:tc>
+                  <a:txBody>
+                    <a:bodyPr/>
+                    <a:lstStyle/>
+                    <a:p>
+                      <a:r>
+                        <a:rPr sz="1300" b="1">
+                          <a:latin typeface="Courier New"/>
+                        </a:rPr>
+                        <a:t>post   → posts</a:t>
+                      </a:r>
+                    </a:p>
+                  </a:txBody>
+                  <a:tcPr anchor="ctr" marL="91440" marR="91440" marT="18288" marB="18288"/>
+                </a:tc>
+              </a:tr>
+              <a:tr h="301752">
+                <a:tc>
+                  <a:txBody>
+                    <a:bodyPr/>
+                    <a:lstStyle/>
+                    <a:p>
+                      <a:r>
+                        <a:rPr sz="1300" b="1">
+                          <a:latin typeface="Courier New"/>
+                        </a:rPr>
+                        <a:t>author → users</a:t>
+                      </a:r>
+                    </a:p>
+                  </a:txBody>
+                  <a:tcPr anchor="ctr" marL="91440" marR="91440" marT="18288" marB="18288"/>
+                </a:tc>
+              </a:tr>
+              <a:tr h="301752">
+                <a:tc>
+                  <a:txBody>
+                    <a:bodyPr/>
+                    <a:lstStyle/>
+                    <a:p>
+                      <a:r>
+                        <a:rPr sz="1300">
+                          <a:latin typeface="Courier New"/>
+                        </a:rPr>
+                        <a:t>body</a:t>
+                      </a:r>
+                    </a:p>
+                  </a:txBody>
+                  <a:tcPr anchor="ctr" marL="91440" marR="91440" marT="18288" marB="18288"/>
+                </a:tc>
+              </a:tr>
+              <a:tr h="301752">
+                <a:tc>
+                  <a:txBody>
+                    <a:bodyPr/>
+                    <a:lstStyle/>
+                    <a:p>
+                      <a:r>
+                        <a:rPr sz="1300">
+                          <a:latin typeface="Courier New"/>
+                        </a:rPr>
+                        <a:t>created</a:t>
+                      </a:r>
+                    </a:p>
+                  </a:txBody>
+                  <a:tcPr anchor="ctr" marL="91440" marR="91440" marT="18288" marB="18288"/>
+                </a:tc>
+              </a:tr>
+            </a:tbl>
+          </a:graphicData>
+        </a:graphic>
+      </p:graphicFrame>
+      <p:graphicFrame>
+        <p:nvGraphicFramePr>
+          <p:cNvPr id="7" name="ER likes"/>
+          <p:cNvGraphicFramePr>
+            <a:graphicFrameLocks noGrp="1"/>
+          </p:cNvGraphicFramePr>
+          <p:nvPr/>
+        </p:nvGraphicFramePr>
+        <p:xfrm>
+          <a:off x="8686800" y="4389120"/>
+          <a:ext cx="2743200" cy="1508760"/>
+        </p:xfrm>
+        <a:graphic>
+          <a:graphicData uri="http://schemas.openxmlformats.org/drawingml/2006/table">
+            <a:tbl>
+              <a:tblPr firstRow="1" bandRow="1">
+                <a:tableStyleId>{5C22544A-7EE6-4342-B048-85BDC9FD1C3A}</a:tableStyleId>
+              </a:tblPr>
+              <a:tblGrid>
+                <a:gridCol w="2743200"/>
+              </a:tblGrid>
+              <a:tr h="301752">
+                <a:tc>
+                  <a:txBody>
+                    <a:bodyPr/>
+                    <a:lstStyle/>
+                    <a:p>
+                      <a:r>
+                        <a:rPr sz="1300" b="1"/>
+                        <a:t>likes</a:t>
+                      </a:r>
+                    </a:p>
+                  </a:txBody>
+                  <a:tcPr anchor="ctr" marL="91440" marR="91440" marT="18288" marB="18288"/>
+                </a:tc>
+              </a:tr>
+              <a:tr h="301752">
+                <a:tc>
+                  <a:txBody>
+                    <a:bodyPr/>
+                    <a:lstStyle/>
+                    <a:p>
+                      <a:r>
+                        <a:rPr sz="1300">
+                          <a:latin typeface="Courier New"/>
+                        </a:rPr>
+                        <a:t>id</a:t>
+                      </a:r>
+                    </a:p>
+                  </a:txBody>
+                  <a:tcPr anchor="ctr" marL="91440" marR="91440" marT="18288" marB="18288"/>
+                </a:tc>
+              </a:tr>
+              <a:tr h="301752">
+                <a:tc>
+                  <a:txBody>
+                    <a:bodyPr/>
+                    <a:lstStyle/>
+                    <a:p>
+                      <a:r>
+                        <a:rPr sz="1300" b="1">
+                          <a:latin typeface="Courier New"/>
+                        </a:rPr>
+                        <a:t>post → posts</a:t>
+                      </a:r>
+                    </a:p>
+                  </a:txBody>
+                  <a:tcPr anchor="ctr" marL="91440" marR="91440" marT="18288" marB="18288"/>
+                </a:tc>
+              </a:tr>
+              <a:tr h="301752">
+                <a:tc>
+                  <a:txBody>
+                    <a:bodyPr/>
+                    <a:lstStyle/>
+                    <a:p>
+                      <a:r>
+                        <a:rPr sz="1300" b="1">
+                          <a:latin typeface="Courier New"/>
+                        </a:rPr>
+                        <a:t>user → users</a:t>
+                      </a:r>
+                    </a:p>
+                  </a:txBody>
+                  <a:tcPr anchor="ctr" marL="91440" marR="91440" marT="18288" marB="18288"/>
+                </a:tc>
+              </a:tr>
+              <a:tr h="301752">
+                <a:tc>
+                  <a:txBody>
+                    <a:bodyPr/>
+                    <a:lstStyle/>
+                    <a:p>
+                      <a:r>
+                        <a:rPr sz="1300">
+                          <a:latin typeface="Courier New"/>
+                        </a:rPr>
+                        <a:t>created</a:t>
+                      </a:r>
+                    </a:p>
+                  </a:txBody>
+                  <a:tcPr anchor="ctr" marL="91440" marR="91440" marT="18288" marB="18288"/>
+                </a:tc>
+              </a:tr>
+            </a:tbl>
+          </a:graphicData>
+        </a:graphic>
+      </p:graphicFrame>
+      <p:cxnSp>
+        <p:nvCxnSpPr>
+          <p:cNvPr id="8" name="Connector 7"/>
+          <p:cNvCxnSpPr/>
+          <p:nvPr/>
+        </p:nvCxnSpPr>
         <p:spPr>
-          <a:xfrm>
-            <a:off x="768096" y="1691640"/>
-            <a:ext cx="10655503" cy="4687062"/>
+          <a:xfrm flipV="1">
+            <a:off x="6099048" y="3941063"/>
+            <a:ext cx="0" cy="402337"/>
           </a:xfrm>
-          <a:prstGeom prst="roundRect">
-            <a:avLst>
-              <a:gd name="adj" fmla="val 4000"/>
-            </a:avLst>
+          <a:prstGeom prst="line">
+            <a:avLst/>
           </a:prstGeom>
-          <a:solidFill>
-            <a:srgbClr val="1F2430"/>
-          </a:solidFill>
-          <a:ln>
-            <a:noFill/>
+          <a:ln w="22225">
+            <a:solidFill>
+              <a:srgbClr val="404040"/>
+            </a:solidFill>
+            <a:tailEnd type="triangle" w="med" len="med"/>
           </a:ln>
-          <a:effectLst/>
         </p:spPr>
         <p:style>
-          <a:lnRef idx="1">
+          <a:lnRef idx="2">
             <a:schemeClr val="accent1"/>
           </a:lnRef>
-          <a:fillRef idx="3">
+          <a:fillRef idx="0">
             <a:schemeClr val="accent1"/>
           </a:fillRef>
-          <a:effectRef idx="2">
+          <a:effectRef idx="1">
             <a:schemeClr val="accent1"/>
           </a:effectRef>
           <a:fontRef idx="minor">
-            <a:schemeClr val="lt1"/>
+            <a:schemeClr val="tx1"/>
           </a:fontRef>
         </p:style>
-        <p:txBody>
-          <a:bodyPr wrap="none" lIns="274320" tIns="201168" rIns="274320" bIns="201168" rtlCol="0" anchor="t"/>
+      </p:cxnSp>
+      <p:cxnSp>
+        <p:nvCxnSpPr>
+          <p:cNvPr id="9" name="Connector 8"/>
+          <p:cNvCxnSpPr/>
+          <p:nvPr/>
+        </p:nvCxnSpPr>
+        <p:spPr>
+          <a:xfrm flipH="1">
+            <a:off x="7516368" y="2537460"/>
+            <a:ext cx="1124712" cy="0"/>
+          </a:xfrm>
+          <a:prstGeom prst="line">
+            <a:avLst/>
+          </a:prstGeom>
+          <a:ln w="22225">
+            <a:solidFill>
+              <a:srgbClr val="404040"/>
+            </a:solidFill>
+            <a:tailEnd type="triangle" w="med" len="med"/>
+          </a:ln>
+        </p:spPr>
+        <p:style>
+          <a:lnRef idx="2">
+            <a:schemeClr val="accent1"/>
+          </a:lnRef>
+          <a:fillRef idx="0">
+            <a:schemeClr val="accent1"/>
+          </a:fillRef>
+          <a:effectRef idx="1">
+            <a:schemeClr val="accent1"/>
+          </a:effectRef>
+          <a:fontRef idx="minor">
+            <a:schemeClr val="tx1"/>
+          </a:fontRef>
+        </p:style>
+      </p:cxnSp>
+      <p:cxnSp>
+        <p:nvCxnSpPr>
+          <p:cNvPr id="10" name="Connector 9"/>
+          <p:cNvCxnSpPr/>
+          <p:nvPr/>
+        </p:nvCxnSpPr>
+        <p:spPr>
+          <a:xfrm flipH="1">
+            <a:off x="7516368" y="2839212"/>
+            <a:ext cx="1124712" cy="0"/>
+          </a:xfrm>
+          <a:prstGeom prst="line">
+            <a:avLst/>
+          </a:prstGeom>
+          <a:ln w="22225">
+            <a:solidFill>
+              <a:srgbClr val="404040"/>
+            </a:solidFill>
+            <a:tailEnd type="triangle" w="med" len="med"/>
+          </a:ln>
+        </p:spPr>
+        <p:style>
+          <a:lnRef idx="2">
+            <a:schemeClr val="accent1"/>
+          </a:lnRef>
+          <a:fillRef idx="0">
+            <a:schemeClr val="accent1"/>
+          </a:fillRef>
+          <a:effectRef idx="1">
+            <a:schemeClr val="accent1"/>
+          </a:effectRef>
+          <a:fontRef idx="minor">
+            <a:schemeClr val="tx1"/>
+          </a:fontRef>
+        </p:style>
+      </p:cxnSp>
+      <p:cxnSp>
+        <p:nvCxnSpPr>
+          <p:cNvPr id="11" name="Connector 10"/>
+          <p:cNvCxnSpPr/>
+          <p:nvPr/>
+        </p:nvCxnSpPr>
+        <p:spPr>
+          <a:xfrm>
+            <a:off x="3557015" y="5143500"/>
+            <a:ext cx="1124713" cy="0"/>
+          </a:xfrm>
+          <a:prstGeom prst="line">
+            <a:avLst/>
+          </a:prstGeom>
+          <a:ln w="22225">
+            <a:solidFill>
+              <a:srgbClr val="404040"/>
+            </a:solidFill>
+            <a:tailEnd type="triangle" w="med" len="med"/>
+          </a:ln>
+        </p:spPr>
+        <p:style>
+          <a:lnRef idx="2">
+            <a:schemeClr val="accent1"/>
+          </a:lnRef>
+          <a:fillRef idx="0">
+            <a:schemeClr val="accent1"/>
+          </a:fillRef>
+          <a:effectRef idx="1">
+            <a:schemeClr val="accent1"/>
+          </a:effectRef>
+          <a:fontRef idx="minor">
+            <a:schemeClr val="tx1"/>
+          </a:fontRef>
+        </p:style>
+      </p:cxnSp>
+      <p:cxnSp>
+        <p:nvCxnSpPr>
+          <p:cNvPr id="12" name="Connector 11"/>
+          <p:cNvCxnSpPr/>
+          <p:nvPr/>
+        </p:nvCxnSpPr>
+        <p:spPr>
+          <a:xfrm flipV="1">
+            <a:off x="2962656" y="3140964"/>
+            <a:ext cx="1719072" cy="1202436"/>
+          </a:xfrm>
+          <a:prstGeom prst="line">
+            <a:avLst/>
+          </a:prstGeom>
+          <a:ln w="22225">
+            <a:solidFill>
+              <a:srgbClr val="404040"/>
+            </a:solidFill>
+            <a:tailEnd type="triangle" w="med" len="med"/>
+          </a:ln>
+        </p:spPr>
+        <p:style>
+          <a:lnRef idx="2">
+            <a:schemeClr val="accent1"/>
+          </a:lnRef>
+          <a:fillRef idx="0">
+            <a:schemeClr val="accent1"/>
+          </a:fillRef>
+          <a:effectRef idx="1">
+            <a:schemeClr val="accent1"/>
+          </a:effectRef>
+          <a:fontRef idx="minor">
+            <a:schemeClr val="tx1"/>
+          </a:fontRef>
+        </p:style>
+      </p:cxnSp>
+      <p:cxnSp>
+        <p:nvCxnSpPr>
+          <p:cNvPr id="13" name="Connector 12"/>
+          <p:cNvCxnSpPr/>
+          <p:nvPr/>
+        </p:nvCxnSpPr>
+        <p:spPr>
+          <a:xfrm flipH="1">
+            <a:off x="7516368" y="5143500"/>
+            <a:ext cx="1124712" cy="0"/>
+          </a:xfrm>
+          <a:prstGeom prst="line">
+            <a:avLst/>
+          </a:prstGeom>
+          <a:ln w="22225">
+            <a:solidFill>
+              <a:srgbClr val="404040"/>
+            </a:solidFill>
+            <a:tailEnd type="triangle" w="med" len="med"/>
+          </a:ln>
+        </p:spPr>
+        <p:style>
+          <a:lnRef idx="2">
+            <a:schemeClr val="accent1"/>
+          </a:lnRef>
+          <a:fillRef idx="0">
+            <a:schemeClr val="accent1"/>
+          </a:fillRef>
+          <a:effectRef idx="1">
+            <a:schemeClr val="accent1"/>
+          </a:effectRef>
+          <a:fontRef idx="minor">
+            <a:schemeClr val="tx1"/>
+          </a:fontRef>
+        </p:style>
+      </p:cxnSp>
+      <p:cxnSp>
+        <p:nvCxnSpPr>
+          <p:cNvPr id="14" name="Connector 13"/>
+          <p:cNvCxnSpPr/>
+          <p:nvPr/>
+        </p:nvCxnSpPr>
+        <p:spPr>
+          <a:xfrm flipH="1" flipV="1">
+            <a:off x="7516368" y="3442716"/>
+            <a:ext cx="1719072" cy="900684"/>
+          </a:xfrm>
+          <a:prstGeom prst="line">
+            <a:avLst/>
+          </a:prstGeom>
+          <a:ln w="22225">
+            <a:solidFill>
+              <a:srgbClr val="404040"/>
+            </a:solidFill>
+            <a:tailEnd type="triangle" w="med" len="med"/>
+          </a:ln>
+        </p:spPr>
+        <p:style>
+          <a:lnRef idx="2">
+            <a:schemeClr val="accent1"/>
+          </a:lnRef>
+          <a:fillRef idx="0">
+            <a:schemeClr val="accent1"/>
+          </a:fillRef>
+          <a:effectRef idx="1">
+            <a:schemeClr val="accent1"/>
+          </a:effectRef>
+          <a:fontRef idx="minor">
+            <a:schemeClr val="tx1"/>
+          </a:fontRef>
+        </p:style>
+      </p:cxnSp>
+      <p:sp>
+        <p:nvSpPr>
+          <p:cNvPr id="15" name="TextBox 14"/>
+          <p:cNvSpPr txBox="1"/>
+          <p:nvPr/>
+        </p:nvSpPr>
+        <p:spPr>
+          <a:xfrm>
+            <a:off x="768096" y="1828800"/>
+            <a:ext cx="3566160" cy="2194560"/>
+          </a:xfrm>
+          <a:prstGeom prst="rect">
+            <a:avLst/>
+          </a:prstGeom>
+          <a:noFill/>
+        </p:spPr>
+        <p:txBody>
+          <a:bodyPr wrap="square" lIns="0" rIns="0" tIns="0" bIns="0" anchor="ctr">
+            <a:spAutoFit/>
+          </a:bodyPr>
           <a:lstStyle/>
           <a:p>
             <a:pPr algn="l"/>
             <a:r>
-              <a:rPr sz="1300">
-                <a:solidFill>
-                  <a:srgbClr val="E6E9EF"/>
-                </a:solidFill>
-                <a:latin typeface="Courier New"/>
-              </a:rPr>
-              <a:t>┌──────────────────────┐            ┌──────────────────────┐</a:t>
-            </a:r>
-          </a:p>
-          <a:p>
-            <a:pPr algn="l"/>
-            <a:r>
-              <a:rPr sz="1300">
-                <a:solidFill>
-                  <a:srgbClr val="E6E9EF"/>
-                </a:solidFill>
-                <a:latin typeface="Courier New"/>
-              </a:rPr>
-              <a:t>│        users         │ 1        * │        posts         │</a:t>
-            </a:r>
-          </a:p>
-          <a:p>
-            <a:pPr algn="l"/>
-            <a:r>
-              <a:rPr sz="1300">
-                <a:solidFill>
-                  <a:srgbClr val="E6E9EF"/>
-                </a:solidFill>
-                <a:latin typeface="Courier New"/>
-              </a:rPr>
-              <a:t>│──────────────────────│◄───────────│──────────────────────│</a:t>
-            </a:r>
-          </a:p>
-          <a:p>
-            <a:pPr algn="l"/>
-            <a:r>
-              <a:rPr sz="1300">
-                <a:solidFill>
-                  <a:srgbClr val="E6E9EF"/>
-                </a:solidFill>
-                <a:latin typeface="Courier New"/>
-              </a:rPr>
-              <a:t>│ id                   │   author   │ id                   │</a:t>
-            </a:r>
-          </a:p>
-          <a:p>
-            <a:pPr algn="l"/>
-            <a:r>
-              <a:rPr sz="1300">
-                <a:solidFill>
-                  <a:srgbClr val="E6E9EF"/>
-                </a:solidFill>
-                <a:latin typeface="Courier New"/>
-              </a:rPr>
-              <a:t>│ username (unik)      │            │ author   → users     │</a:t>
-            </a:r>
-          </a:p>
-          <a:p>
-            <a:pPr algn="l"/>
-            <a:r>
-              <a:rPr sz="1300">
-                <a:solidFill>
-                  <a:srgbClr val="E6E9EF"/>
-                </a:solidFill>
-                <a:latin typeface="Courier New"/>
-              </a:rPr>
-              <a:t>│ name                 │            │ title                │</a:t>
-            </a:r>
-          </a:p>
-          <a:p>
-            <a:pPr algn="l"/>
-            <a:r>
-              <a:rPr sz="1300">
-                <a:solidFill>
-                  <a:srgbClr val="E6E9EF"/>
-                </a:solidFill>
-                <a:latin typeface="Courier New"/>
-              </a:rPr>
-              <a:t>│ email                │            │ body                 │</a:t>
-            </a:r>
-          </a:p>
-          <a:p>
-            <a:pPr algn="l"/>
-            <a:r>
-              <a:rPr sz="1300">
-                <a:solidFill>
-                  <a:srgbClr val="E6E9EF"/>
-                </a:solidFill>
-                <a:latin typeface="Courier New"/>
-              </a:rPr>
-              <a:t>│ bio                  │            │ created              │</a:t>
-            </a:r>
-          </a:p>
-          <a:p>
-            <a:pPr algn="l"/>
-            <a:r>
-              <a:rPr sz="1300">
-                <a:solidFill>
-                  <a:srgbClr val="E6E9EF"/>
-                </a:solidFill>
-                <a:latin typeface="Courier New"/>
-              </a:rPr>
-              <a:t>│ website              │            └──────────────────────┘</a:t>
-            </a:r>
-          </a:p>
-          <a:p>
-            <a:pPr algn="l"/>
-            <a:r>
-              <a:rPr sz="1300">
-                <a:solidFill>
-                  <a:srgbClr val="E6E9EF"/>
-                </a:solidFill>
-                <a:latin typeface="Courier New"/>
-              </a:rPr>
-              <a:t>└──────────────────────┘                 ▲ 1          ▲ 1</a:t>
-            </a:r>
-          </a:p>
-          <a:p>
-            <a:pPr algn="l"/>
-            <a:r>
-              <a:rPr sz="1300">
-                <a:solidFill>
-                  <a:srgbClr val="E6E9EF"/>
-                </a:solidFill>
-                <a:latin typeface="Courier New"/>
-              </a:rPr>
-              <a:t>                                         │ post       │ post</a:t>
-            </a:r>
-          </a:p>
-          <a:p>
-            <a:pPr algn="l"/>
-            <a:r>
-              <a:rPr sz="1300">
-                <a:solidFill>
-                  <a:srgbClr val="E6E9EF"/>
-                </a:solidFill>
-                <a:latin typeface="Courier New"/>
-              </a:rPr>
-              <a:t>                                         │ *          │ *</a:t>
-            </a:r>
-          </a:p>
-          <a:p>
-            <a:pPr algn="l"/>
-            <a:r>
-              <a:rPr sz="1300">
-                <a:solidFill>
-                  <a:srgbClr val="E6E9EF"/>
-                </a:solidFill>
-                <a:latin typeface="Courier New"/>
-              </a:rPr>
-              <a:t>┌──────────────────────┐   ┌─────────────┴────┐  ┌────┴─────────────┐</a:t>
-            </a:r>
-          </a:p>
-          <a:p>
-            <a:pPr algn="l"/>
-            <a:r>
-              <a:rPr sz="1300">
-                <a:solidFill>
-                  <a:srgbClr val="E6E9EF"/>
-                </a:solidFill>
-                <a:latin typeface="Courier New"/>
-              </a:rPr>
-              <a:t>│       follows        │   │     comments     │  │      likes       │</a:t>
-            </a:r>
-          </a:p>
-          <a:p>
-            <a:pPr algn="l"/>
-            <a:r>
-              <a:rPr sz="1300">
-                <a:solidFill>
-                  <a:srgbClr val="E6E9EF"/>
-                </a:solidFill>
-                <a:latin typeface="Courier New"/>
-              </a:rPr>
-              <a:t>│──────────────────────│   │──────────────────│  │──────────────────│</a:t>
-            </a:r>
-          </a:p>
-          <a:p>
-            <a:pPr algn="l"/>
-            <a:r>
-              <a:rPr sz="1300">
-                <a:solidFill>
-                  <a:srgbClr val="E6E9EF"/>
-                </a:solidFill>
-                <a:latin typeface="Courier New"/>
-              </a:rPr>
-              <a:t>│ id                   │   │ id               │  │ id               │</a:t>
-            </a:r>
-          </a:p>
-          <a:p>
-            <a:pPr algn="l"/>
-            <a:r>
-              <a:rPr sz="1300">
-                <a:solidFill>
-                  <a:srgbClr val="E6E9EF"/>
-                </a:solidFill>
-                <a:latin typeface="Courier New"/>
-              </a:rPr>
-              <a:t>│ follower  → users    │   │ post   → posts   │  │ post  → posts    │</a:t>
-            </a:r>
-          </a:p>
-          <a:p>
-            <a:pPr algn="l"/>
-            <a:r>
-              <a:rPr sz="1300">
-                <a:solidFill>
-                  <a:srgbClr val="E6E9EF"/>
-                </a:solidFill>
-                <a:latin typeface="Courier New"/>
-              </a:rPr>
-              <a:t>│ following → users    │   │ author → users   │  │ user  → users    │</a:t>
-            </a:r>
-          </a:p>
-          <a:p>
-            <a:pPr algn="l"/>
-            <a:r>
-              <a:rPr sz="1300">
-                <a:solidFill>
-                  <a:srgbClr val="E6E9EF"/>
-                </a:solidFill>
-                <a:latin typeface="Courier New"/>
-              </a:rPr>
-              <a:t>│ created              │   │ body             │  │ created          │</a:t>
-            </a:r>
-          </a:p>
-          <a:p>
-            <a:pPr algn="l"/>
-            <a:r>
-              <a:rPr sz="1300">
-                <a:solidFill>
-                  <a:srgbClr val="E6E9EF"/>
-                </a:solidFill>
-                <a:latin typeface="Courier New"/>
-              </a:rPr>
-              <a:t>└──────────────────────┘   │ created          │  └──────────────────┘</a:t>
-            </a:r>
-          </a:p>
-          <a:p>
-            <a:pPr algn="l"/>
-            <a:r>
-              <a:rPr sz="1300">
-                <a:solidFill>
-                  <a:srgbClr val="E6E9EF"/>
-                </a:solidFill>
-                <a:latin typeface="Courier New"/>
-              </a:rPr>
-              <a:t>                           └──────────────────┘</a:t>
+              <a:rPr sz="1400" b="0" i="0">
+                <a:solidFill>
+                  <a:srgbClr val="595959"/>
+                </a:solidFill>
+              </a:rPr>
+              <a:t>Pilen går från relationsfältet till tabellen det pekar på.</a:t>
+            </a:r>
+          </a:p>
+          <a:p>
+            <a:pPr>
+              <a:spcBef>
+                <a:spcPts val="1000"/>
+              </a:spcBef>
+            </a:pPr>
+            <a:r>
+              <a:rPr sz="1400">
+                <a:solidFill>
+                  <a:srgbClr val="595959"/>
+                </a:solidFill>
+              </a:rPr>
+              <a:t>Många → en: många inlägg kan ha samma author.</a:t>
+            </a:r>
+          </a:p>
+          <a:p>
+            <a:pPr>
+              <a:spcBef>
+                <a:spcPts val="1000"/>
+              </a:spcBef>
+            </a:pPr>
+            <a:r>
+              <a:rPr sz="1400">
+                <a:solidFill>
+                  <a:srgbClr val="595959"/>
+                </a:solidFill>
+              </a:rPr>
+              <a:t>likes och follows är kopplingstabeller (N:M).</a:t>
             </a:r>
           </a:p>
         </p:txBody>
@@ -47139,148 +48212,6 @@
       </p:sp>
       <p:sp>
         <p:nvSpPr>
-          <p:cNvPr id="3" name="Rounded Rectangle 2"/>
-          <p:cNvSpPr/>
-          <p:nvPr/>
-        </p:nvSpPr>
-        <p:spPr>
-          <a:xfrm>
-            <a:off x="768096" y="1691640"/>
-            <a:ext cx="10655503" cy="2900679"/>
-          </a:xfrm>
-          <a:prstGeom prst="roundRect">
-            <a:avLst>
-              <a:gd name="adj" fmla="val 4000"/>
-            </a:avLst>
-          </a:prstGeom>
-          <a:solidFill>
-            <a:srgbClr val="1F2430"/>
-          </a:solidFill>
-          <a:ln>
-            <a:noFill/>
-          </a:ln>
-          <a:effectLst/>
-        </p:spPr>
-        <p:style>
-          <a:lnRef idx="1">
-            <a:schemeClr val="accent1"/>
-          </a:lnRef>
-          <a:fillRef idx="3">
-            <a:schemeClr val="accent1"/>
-          </a:fillRef>
-          <a:effectRef idx="2">
-            <a:schemeClr val="accent1"/>
-          </a:effectRef>
-          <a:fontRef idx="minor">
-            <a:schemeClr val="lt1"/>
-          </a:fontRef>
-        </p:style>
-        <p:txBody>
-          <a:bodyPr wrap="none" lIns="274320" tIns="201168" rIns="274320" bIns="201168" rtlCol="0" anchor="t"/>
-          <a:lstStyle/>
-          <a:p>
-            <a:pPr algn="l">
-              <a:spcAft>
-                <a:spcPts val="600"/>
-              </a:spcAft>
-            </a:pPr>
-            <a:r>
-              <a:rPr sz="1200" b="1">
-                <a:solidFill>
-                  <a:srgbClr val="8B95A7"/>
-                </a:solidFill>
-              </a:rPr>
-              <a:t>tabellen users</a:t>
-            </a:r>
-          </a:p>
-          <a:p>
-            <a:pPr algn="l"/>
-            <a:r>
-              <a:rPr sz="2000">
-                <a:solidFill>
-                  <a:srgbClr val="E6E9EF"/>
-                </a:solidFill>
-                <a:latin typeface="Courier New"/>
-              </a:rPr>
-              <a:t>          ┌──────────┬────────────┬──────────────────┐</a:t>
-            </a:r>
-          </a:p>
-          <a:p>
-            <a:pPr algn="l"/>
-            <a:r>
-              <a:rPr sz="2000">
-                <a:solidFill>
-                  <a:srgbClr val="E6E9EF"/>
-                </a:solidFill>
-                <a:latin typeface="Courier New"/>
-              </a:rPr>
-              <a:t>          │ id       │ username   │ name             │  ← kolumner</a:t>
-            </a:r>
-          </a:p>
-          <a:p>
-            <a:pPr algn="l"/>
-            <a:r>
-              <a:rPr sz="2000">
-                <a:solidFill>
-                  <a:srgbClr val="E6E9EF"/>
-                </a:solidFill>
-                <a:latin typeface="Courier New"/>
-              </a:rPr>
-              <a:t>          ├──────────┼────────────┼──────────────────┤</a:t>
-            </a:r>
-          </a:p>
-          <a:p>
-            <a:pPr algn="l"/>
-            <a:r>
-              <a:rPr sz="2000">
-                <a:solidFill>
-                  <a:srgbClr val="E6E9EF"/>
-                </a:solidFill>
-                <a:latin typeface="Courier New"/>
-              </a:rPr>
-              <a:t>   rad →  │ u1       │ anna       │ Anna Andersson   │</a:t>
-            </a:r>
-          </a:p>
-          <a:p>
-            <a:pPr algn="l"/>
-            <a:r>
-              <a:rPr sz="2000">
-                <a:solidFill>
-                  <a:srgbClr val="E6E9EF"/>
-                </a:solidFill>
-                <a:latin typeface="Courier New"/>
-              </a:rPr>
-              <a:t>   rad →  │ u2       │ bertil     │ Bertil Berg      │</a:t>
-            </a:r>
-          </a:p>
-          <a:p>
-            <a:pPr algn="l"/>
-            <a:r>
-              <a:rPr sz="2000">
-                <a:solidFill>
-                  <a:srgbClr val="E6E9EF"/>
-                </a:solidFill>
-                <a:latin typeface="Courier New"/>
-              </a:rPr>
-              <a:t>   rad →  │ u3       │ cissi      │ Cecilia Carlsson │</a:t>
-            </a:r>
-          </a:p>
-          <a:p>
-            <a:pPr algn="l"/>
-            <a:r>
-              <a:rPr sz="2000">
-                <a:solidFill>
-                  <a:srgbClr val="E6E9EF"/>
-                </a:solidFill>
-                <a:latin typeface="Courier New"/>
-              </a:rPr>
-              <a:t>          └──────────┴────────────┴──────────────────┘</a:t>
-            </a:r>
-          </a:p>
-        </p:txBody>
-      </p:sp>
-      <p:sp>
-        <p:nvSpPr>
           <p:cNvPr id="4" name="TextBox 3"/>
           <p:cNvSpPr txBox="1"/>
           <p:nvPr/>
@@ -47313,6 +48244,375 @@
                 </a:solidFill>
               </a:rPr>
               <a:t>I PocketBase: tabell = collection, rad = record, kolumn = field. Varje kolumn har en datatyp: text, tal, datum, ja/nej …</a:t>
+            </a:r>
+          </a:p>
+        </p:txBody>
+      </p:sp>
+      <p:graphicFrame>
+        <p:nvGraphicFramePr>
+          <p:cNvPr id="5" name="Tabell users"/>
+          <p:cNvGraphicFramePr>
+            <a:graphicFrameLocks noGrp="1"/>
+          </p:cNvGraphicFramePr>
+          <p:nvPr/>
+        </p:nvGraphicFramePr>
+        <p:xfrm>
+          <a:off x="2377440" y="2240280"/>
+          <a:ext cx="7132320" cy="2011680"/>
+        </p:xfrm>
+        <a:graphic>
+          <a:graphicData uri="http://schemas.openxmlformats.org/drawingml/2006/table">
+            <a:tbl>
+              <a:tblPr firstRow="1" bandRow="1">
+                <a:tableStyleId>{5C22544A-7EE6-4342-B048-85BDC9FD1C3A}</a:tableStyleId>
+              </a:tblPr>
+              <a:tblGrid>
+                <a:gridCol w="1463040"/>
+                <a:gridCol w="2377440"/>
+                <a:gridCol w="3291840"/>
+              </a:tblGrid>
+              <a:tr h="502920">
+                <a:tc>
+                  <a:txBody>
+                    <a:bodyPr/>
+                    <a:lstStyle/>
+                    <a:p>
+                      <a:r>
+                        <a:rPr sz="1800" b="1"/>
+                        <a:t>id</a:t>
+                      </a:r>
+                    </a:p>
+                  </a:txBody>
+                  <a:tcPr anchor="ctr" marL="91440" marR="91440" marT="18288" marB="18288"/>
+                </a:tc>
+                <a:tc>
+                  <a:txBody>
+                    <a:bodyPr/>
+                    <a:lstStyle/>
+                    <a:p>
+                      <a:r>
+                        <a:rPr sz="1800" b="1"/>
+                        <a:t>username</a:t>
+                      </a:r>
+                    </a:p>
+                  </a:txBody>
+                  <a:tcPr anchor="ctr" marL="91440" marR="91440" marT="18288" marB="18288"/>
+                </a:tc>
+                <a:tc>
+                  <a:txBody>
+                    <a:bodyPr/>
+                    <a:lstStyle/>
+                    <a:p>
+                      <a:r>
+                        <a:rPr sz="1800" b="1"/>
+                        <a:t>name</a:t>
+                      </a:r>
+                    </a:p>
+                  </a:txBody>
+                  <a:tcPr anchor="ctr" marL="91440" marR="91440" marT="18288" marB="18288"/>
+                </a:tc>
+              </a:tr>
+              <a:tr h="502920">
+                <a:tc>
+                  <a:txBody>
+                    <a:bodyPr/>
+                    <a:lstStyle/>
+                    <a:p>
+                      <a:r>
+                        <a:rPr sz="1800">
+                          <a:latin typeface="Courier New"/>
+                        </a:rPr>
+                        <a:t>u1</a:t>
+                      </a:r>
+                    </a:p>
+                  </a:txBody>
+                  <a:tcPr anchor="ctr" marL="91440" marR="91440" marT="18288" marB="18288"/>
+                </a:tc>
+                <a:tc>
+                  <a:txBody>
+                    <a:bodyPr/>
+                    <a:lstStyle/>
+                    <a:p>
+                      <a:r>
+                        <a:rPr sz="1800">
+                          <a:latin typeface="Courier New"/>
+                        </a:rPr>
+                        <a:t>anna</a:t>
+                      </a:r>
+                    </a:p>
+                  </a:txBody>
+                  <a:tcPr anchor="ctr" marL="91440" marR="91440" marT="18288" marB="18288"/>
+                </a:tc>
+                <a:tc>
+                  <a:txBody>
+                    <a:bodyPr/>
+                    <a:lstStyle/>
+                    <a:p>
+                      <a:r>
+                        <a:rPr sz="1800"/>
+                        <a:t>Anna Andersson</a:t>
+                      </a:r>
+                    </a:p>
+                  </a:txBody>
+                  <a:tcPr anchor="ctr" marL="91440" marR="91440" marT="18288" marB="18288"/>
+                </a:tc>
+              </a:tr>
+              <a:tr h="502920">
+                <a:tc>
+                  <a:txBody>
+                    <a:bodyPr/>
+                    <a:lstStyle/>
+                    <a:p>
+                      <a:r>
+                        <a:rPr sz="1800">
+                          <a:latin typeface="Courier New"/>
+                        </a:rPr>
+                        <a:t>u2</a:t>
+                      </a:r>
+                    </a:p>
+                  </a:txBody>
+                  <a:tcPr anchor="ctr" marL="91440" marR="91440" marT="18288" marB="18288"/>
+                </a:tc>
+                <a:tc>
+                  <a:txBody>
+                    <a:bodyPr/>
+                    <a:lstStyle/>
+                    <a:p>
+                      <a:r>
+                        <a:rPr sz="1800">
+                          <a:latin typeface="Courier New"/>
+                        </a:rPr>
+                        <a:t>bertil</a:t>
+                      </a:r>
+                    </a:p>
+                  </a:txBody>
+                  <a:tcPr anchor="ctr" marL="91440" marR="91440" marT="18288" marB="18288"/>
+                </a:tc>
+                <a:tc>
+                  <a:txBody>
+                    <a:bodyPr/>
+                    <a:lstStyle/>
+                    <a:p>
+                      <a:r>
+                        <a:rPr sz="1800"/>
+                        <a:t>Bertil Berg</a:t>
+                      </a:r>
+                    </a:p>
+                  </a:txBody>
+                  <a:tcPr anchor="ctr" marL="91440" marR="91440" marT="18288" marB="18288"/>
+                </a:tc>
+              </a:tr>
+              <a:tr h="502920">
+                <a:tc>
+                  <a:txBody>
+                    <a:bodyPr/>
+                    <a:lstStyle/>
+                    <a:p>
+                      <a:r>
+                        <a:rPr sz="1800">
+                          <a:latin typeface="Courier New"/>
+                        </a:rPr>
+                        <a:t>u3</a:t>
+                      </a:r>
+                    </a:p>
+                  </a:txBody>
+                  <a:tcPr anchor="ctr" marL="91440" marR="91440" marT="18288" marB="18288"/>
+                </a:tc>
+                <a:tc>
+                  <a:txBody>
+                    <a:bodyPr/>
+                    <a:lstStyle/>
+                    <a:p>
+                      <a:r>
+                        <a:rPr sz="1800">
+                          <a:latin typeface="Courier New"/>
+                        </a:rPr>
+                        <a:t>cissi</a:t>
+                      </a:r>
+                    </a:p>
+                  </a:txBody>
+                  <a:tcPr anchor="ctr" marL="91440" marR="91440" marT="18288" marB="18288"/>
+                </a:tc>
+                <a:tc>
+                  <a:txBody>
+                    <a:bodyPr/>
+                    <a:lstStyle/>
+                    <a:p>
+                      <a:r>
+                        <a:rPr sz="1800"/>
+                        <a:t>Cecilia Carlsson</a:t>
+                      </a:r>
+                    </a:p>
+                  </a:txBody>
+                  <a:tcPr anchor="ctr" marL="91440" marR="91440" marT="18288" marB="18288"/>
+                </a:tc>
+              </a:tr>
+            </a:tbl>
+          </a:graphicData>
+        </a:graphic>
+      </p:graphicFrame>
+      <p:sp>
+        <p:nvSpPr>
+          <p:cNvPr id="6" name="TextBox 5"/>
+          <p:cNvSpPr txBox="1"/>
+          <p:nvPr/>
+        </p:nvSpPr>
+        <p:spPr>
+          <a:xfrm>
+            <a:off x="2377440" y="1783080"/>
+            <a:ext cx="3200400" cy="365760"/>
+          </a:xfrm>
+          <a:prstGeom prst="rect">
+            <a:avLst/>
+          </a:prstGeom>
+          <a:noFill/>
+        </p:spPr>
+        <p:txBody>
+          <a:bodyPr wrap="square" lIns="0" rIns="0" tIns="0" bIns="0" anchor="ctr">
+            <a:spAutoFit/>
+          </a:bodyPr>
+          <a:lstStyle/>
+          <a:p>
+            <a:pPr algn="l"/>
+            <a:r>
+              <a:rPr sz="1600" b="1" i="0"/>
+              <a:t>Tabellen users</a:t>
+            </a:r>
+          </a:p>
+        </p:txBody>
+      </p:sp>
+      <p:sp>
+        <p:nvSpPr>
+          <p:cNvPr id="7" name="TextBox 6"/>
+          <p:cNvSpPr txBox="1"/>
+          <p:nvPr/>
+        </p:nvSpPr>
+        <p:spPr>
+          <a:xfrm>
+            <a:off x="9738360" y="2240280"/>
+            <a:ext cx="2194560" cy="502920"/>
+          </a:xfrm>
+          <a:prstGeom prst="rect">
+            <a:avLst/>
+          </a:prstGeom>
+          <a:noFill/>
+        </p:spPr>
+        <p:txBody>
+          <a:bodyPr wrap="square" lIns="0" rIns="0" tIns="0" bIns="0" anchor="ctr">
+            <a:spAutoFit/>
+          </a:bodyPr>
+          <a:lstStyle/>
+          <a:p>
+            <a:pPr algn="l"/>
+            <a:r>
+              <a:rPr sz="1600" b="0" i="0">
+                <a:solidFill>
+                  <a:srgbClr val="595959"/>
+                </a:solidFill>
+              </a:rPr>
+              <a:t>← kolumner (fält)</a:t>
+            </a:r>
+          </a:p>
+        </p:txBody>
+      </p:sp>
+      <p:sp>
+        <p:nvSpPr>
+          <p:cNvPr id="8" name="TextBox 7"/>
+          <p:cNvSpPr txBox="1"/>
+          <p:nvPr/>
+        </p:nvSpPr>
+        <p:spPr>
+          <a:xfrm>
+            <a:off x="1051560" y="2743200"/>
+            <a:ext cx="1188720" cy="502920"/>
+          </a:xfrm>
+          <a:prstGeom prst="rect">
+            <a:avLst/>
+          </a:prstGeom>
+          <a:noFill/>
+        </p:spPr>
+        <p:txBody>
+          <a:bodyPr wrap="square" lIns="0" rIns="0" tIns="0" bIns="0" anchor="ctr">
+            <a:spAutoFit/>
+          </a:bodyPr>
+          <a:lstStyle/>
+          <a:p>
+            <a:pPr algn="r"/>
+            <a:r>
+              <a:rPr sz="1600" b="0" i="0">
+                <a:solidFill>
+                  <a:srgbClr val="595959"/>
+                </a:solidFill>
+              </a:rPr>
+              <a:t>rad →</a:t>
+            </a:r>
+          </a:p>
+        </p:txBody>
+      </p:sp>
+      <p:sp>
+        <p:nvSpPr>
+          <p:cNvPr id="9" name="TextBox 8"/>
+          <p:cNvSpPr txBox="1"/>
+          <p:nvPr/>
+        </p:nvSpPr>
+        <p:spPr>
+          <a:xfrm>
+            <a:off x="1051560" y="3246120"/>
+            <a:ext cx="1188720" cy="502920"/>
+          </a:xfrm>
+          <a:prstGeom prst="rect">
+            <a:avLst/>
+          </a:prstGeom>
+          <a:noFill/>
+        </p:spPr>
+        <p:txBody>
+          <a:bodyPr wrap="square" lIns="0" rIns="0" tIns="0" bIns="0" anchor="ctr">
+            <a:spAutoFit/>
+          </a:bodyPr>
+          <a:lstStyle/>
+          <a:p>
+            <a:pPr algn="r"/>
+            <a:r>
+              <a:rPr sz="1600" b="0" i="0">
+                <a:solidFill>
+                  <a:srgbClr val="595959"/>
+                </a:solidFill>
+              </a:rPr>
+              <a:t>rad →</a:t>
+            </a:r>
+          </a:p>
+        </p:txBody>
+      </p:sp>
+      <p:sp>
+        <p:nvSpPr>
+          <p:cNvPr id="10" name="TextBox 9"/>
+          <p:cNvSpPr txBox="1"/>
+          <p:nvPr/>
+        </p:nvSpPr>
+        <p:spPr>
+          <a:xfrm>
+            <a:off x="1051560" y="3749040"/>
+            <a:ext cx="1188720" cy="502920"/>
+          </a:xfrm>
+          <a:prstGeom prst="rect">
+            <a:avLst/>
+          </a:prstGeom>
+          <a:noFill/>
+        </p:spPr>
+        <p:txBody>
+          <a:bodyPr wrap="square" lIns="0" rIns="0" tIns="0" bIns="0" anchor="ctr">
+            <a:spAutoFit/>
+          </a:bodyPr>
+          <a:lstStyle/>
+          <a:p>
+            <a:pPr algn="r"/>
+            <a:r>
+              <a:rPr sz="1600" b="0" i="0">
+                <a:solidFill>
+                  <a:srgbClr val="595959"/>
+                </a:solidFill>
+              </a:rPr>
+              <a:t>rad →</a:t>
             </a:r>
           </a:p>
         </p:txBody>

</xml_diff>

<commit_message>
Update PocketBase commands in documentation for consistency and clarity
</commit_message>
<xml_diff>
--- a/Databaser och mobilapputveckling - sammanfattning.pptx
+++ b/Databaser och mobilapputveckling - sammanfattning.pptx
@@ -4825,7 +4825,7 @@
           <a:lstStyle/>
           <a:p>
             <a:r>
-              <a:t>Visa live. Varna för att terminalfönstret måste vara öppet. Om Windows säger 'Windows skyddade datorn': Mer information → Kör ändå. E-posten för superuser behöver inte vara riktig, t.ex. admin@example.com.</a:t>
+              <a:t>Visa live. Varna för att terminalfönstret måste vara öppet. Om Windows säger 'Windows skyddade datorn': Mer information → Kör ändå. E-posten för superuser behöver inte vara riktig, t.ex. admin@example.com. .\ behövs i PowerShell (som öppnas med Öppna i terminal). I Kommandotolken (cmd) räcker pocketbase serve.</a:t>
             </a:r>
           </a:p>
         </p:txBody>
@@ -33219,7 +33219,7 @@
                   <a:srgbClr val="595959"/>
                 </a:solidFill>
               </a:rPr>
-              <a:t>.\pocketbase.exe serve i mappen kvittra-pb</a:t>
+              <a:t>.\pocketbase serve i mappen kvittra-pb</a:t>
             </a:r>
           </a:p>
         </p:txBody>
@@ -35165,7 +35165,7 @@
                   <a:srgbClr val="595959"/>
                 </a:solidFill>
               </a:rPr>
-              <a:t>Skriv .\pocketbase.exe serve och tryck Enter</a:t>
+              <a:t>Skriv .\pocketbase serve och tryck Enter</a:t>
             </a:r>
           </a:p>
         </p:txBody>
@@ -35336,7 +35336,7 @@
                 </a:solidFill>
                 <a:latin typeface="Courier New"/>
               </a:rPr>
-              <a:t>PS&gt; .\pocketbase.exe serve</a:t>
+              <a:t>PS&gt; .\pocketbase serve</a:t>
             </a:r>
           </a:p>
           <a:p>
@@ -39446,7 +39446,7 @@
                     <a:p>
                       <a:r>
                         <a:rPr sz="1800"/>
-                        <a:t>Öppna terminal i mappen → .\pocketbase.exe serve</a:t>
+                        <a:t>Öppna terminal i mappen → .\pocketbase serve</a:t>
                       </a:r>
                     </a:p>
                   </a:txBody>

</xml_diff>